<commit_message>
adding modifications for comparisons in Section 3 of paper
</commit_message>
<xml_diff>
--- a/docs/20260430-nucleo-pin-configurations-l4-h2.pptx
+++ b/docs/20260430-nucleo-pin-configurations-l4-h2.pptx
@@ -259,7 +259,7 @@
           <a:p>
             <a:fld id="{B8B67C60-164F-4645-BD88-C03E7D28266F}" type="datetimeFigureOut">
               <a:rPr lang="en-US" smtClean="0"/>
-              <a:t>4/30/2026</a:t>
+              <a:t>5/7/2026</a:t>
             </a:fld>
             <a:endParaRPr lang="en-US"/>
           </a:p>
@@ -457,7 +457,7 @@
           <a:p>
             <a:fld id="{B8B67C60-164F-4645-BD88-C03E7D28266F}" type="datetimeFigureOut">
               <a:rPr lang="en-US" smtClean="0"/>
-              <a:t>4/30/2026</a:t>
+              <a:t>5/7/2026</a:t>
             </a:fld>
             <a:endParaRPr lang="en-US"/>
           </a:p>
@@ -665,7 +665,7 @@
           <a:p>
             <a:fld id="{B8B67C60-164F-4645-BD88-C03E7D28266F}" type="datetimeFigureOut">
               <a:rPr lang="en-US" smtClean="0"/>
-              <a:t>4/30/2026</a:t>
+              <a:t>5/7/2026</a:t>
             </a:fld>
             <a:endParaRPr lang="en-US"/>
           </a:p>
@@ -863,7 +863,7 @@
           <a:p>
             <a:fld id="{B8B67C60-164F-4645-BD88-C03E7D28266F}" type="datetimeFigureOut">
               <a:rPr lang="en-US" smtClean="0"/>
-              <a:t>4/30/2026</a:t>
+              <a:t>5/7/2026</a:t>
             </a:fld>
             <a:endParaRPr lang="en-US"/>
           </a:p>
@@ -1138,7 +1138,7 @@
           <a:p>
             <a:fld id="{B8B67C60-164F-4645-BD88-C03E7D28266F}" type="datetimeFigureOut">
               <a:rPr lang="en-US" smtClean="0"/>
-              <a:t>4/30/2026</a:t>
+              <a:t>5/7/2026</a:t>
             </a:fld>
             <a:endParaRPr lang="en-US"/>
           </a:p>
@@ -1403,7 +1403,7 @@
           <a:p>
             <a:fld id="{B8B67C60-164F-4645-BD88-C03E7D28266F}" type="datetimeFigureOut">
               <a:rPr lang="en-US" smtClean="0"/>
-              <a:t>4/30/2026</a:t>
+              <a:t>5/7/2026</a:t>
             </a:fld>
             <a:endParaRPr lang="en-US"/>
           </a:p>
@@ -1815,7 +1815,7 @@
           <a:p>
             <a:fld id="{B8B67C60-164F-4645-BD88-C03E7D28266F}" type="datetimeFigureOut">
               <a:rPr lang="en-US" smtClean="0"/>
-              <a:t>4/30/2026</a:t>
+              <a:t>5/7/2026</a:t>
             </a:fld>
             <a:endParaRPr lang="en-US"/>
           </a:p>
@@ -1956,7 +1956,7 @@
           <a:p>
             <a:fld id="{B8B67C60-164F-4645-BD88-C03E7D28266F}" type="datetimeFigureOut">
               <a:rPr lang="en-US" smtClean="0"/>
-              <a:t>4/30/2026</a:t>
+              <a:t>5/7/2026</a:t>
             </a:fld>
             <a:endParaRPr lang="en-US"/>
           </a:p>
@@ -2069,7 +2069,7 @@
           <a:p>
             <a:fld id="{B8B67C60-164F-4645-BD88-C03E7D28266F}" type="datetimeFigureOut">
               <a:rPr lang="en-US" smtClean="0"/>
-              <a:t>4/30/2026</a:t>
+              <a:t>5/7/2026</a:t>
             </a:fld>
             <a:endParaRPr lang="en-US"/>
           </a:p>
@@ -2380,7 +2380,7 @@
           <a:p>
             <a:fld id="{B8B67C60-164F-4645-BD88-C03E7D28266F}" type="datetimeFigureOut">
               <a:rPr lang="en-US" smtClean="0"/>
-              <a:t>4/30/2026</a:t>
+              <a:t>5/7/2026</a:t>
             </a:fld>
             <a:endParaRPr lang="en-US"/>
           </a:p>
@@ -2668,7 +2668,7 @@
           <a:p>
             <a:fld id="{B8B67C60-164F-4645-BD88-C03E7D28266F}" type="datetimeFigureOut">
               <a:rPr lang="en-US" smtClean="0"/>
-              <a:t>4/30/2026</a:t>
+              <a:t>5/7/2026</a:t>
             </a:fld>
             <a:endParaRPr lang="en-US"/>
           </a:p>
@@ -2909,7 +2909,7 @@
           <a:p>
             <a:fld id="{B8B67C60-164F-4645-BD88-C03E7D28266F}" type="datetimeFigureOut">
               <a:rPr lang="en-US" smtClean="0"/>
-              <a:t>4/30/2026</a:t>
+              <a:t>5/7/2026</a:t>
             </a:fld>
             <a:endParaRPr lang="en-US"/>
           </a:p>
@@ -4763,6 +4763,149 @@
               <a:rPr lang="en-US" dirty="0"/>
               <a:t>M</a:t>
             </a:r>
+          </a:p>
+        </p:txBody>
+      </p:sp>
+      <p:sp>
+        <p:nvSpPr>
+          <p:cNvPr id="3" name="Rectangle 2">
+            <a:extLst>
+              <a:ext uri="{FF2B5EF4-FFF2-40B4-BE49-F238E27FC236}">
+                <a16:creationId xmlns:a16="http://schemas.microsoft.com/office/drawing/2014/main" id="{033E6CF2-EF83-5344-6495-930092544660}"/>
+              </a:ext>
+            </a:extLst>
+          </p:cNvPr>
+          <p:cNvSpPr/>
+          <p:nvPr/>
+        </p:nvSpPr>
+        <p:spPr>
+          <a:xfrm>
+            <a:off x="9828874" y="2865223"/>
+            <a:ext cx="603600" cy="368120"/>
+          </a:xfrm>
+          <a:prstGeom prst="rect">
+            <a:avLst/>
+          </a:prstGeom>
+          <a:noFill/>
+          <a:ln w="38100">
+            <a:solidFill>
+              <a:schemeClr val="accent5"/>
+            </a:solidFill>
+            <a:prstDash val="dash"/>
+          </a:ln>
+        </p:spPr>
+        <p:style>
+          <a:lnRef idx="2">
+            <a:schemeClr val="accent1">
+              <a:shade val="15000"/>
+            </a:schemeClr>
+          </a:lnRef>
+          <a:fillRef idx="1">
+            <a:schemeClr val="accent1"/>
+          </a:fillRef>
+          <a:effectRef idx="0">
+            <a:schemeClr val="accent1"/>
+          </a:effectRef>
+          <a:fontRef idx="minor">
+            <a:schemeClr val="lt1"/>
+          </a:fontRef>
+        </p:style>
+        <p:txBody>
+          <a:bodyPr rtlCol="0" anchor="ctr"/>
+          <a:lstStyle/>
+          <a:p>
+            <a:pPr algn="ctr"/>
+            <a:endParaRPr lang="en-US"/>
+          </a:p>
+        </p:txBody>
+      </p:sp>
+      <p:sp>
+        <p:nvSpPr>
+          <p:cNvPr id="6" name="Rectangle 5">
+            <a:extLst>
+              <a:ext uri="{FF2B5EF4-FFF2-40B4-BE49-F238E27FC236}">
+                <a16:creationId xmlns:a16="http://schemas.microsoft.com/office/drawing/2014/main" id="{99AFE4DB-ABB8-59FD-6DD0-A9E753971187}"/>
+              </a:ext>
+            </a:extLst>
+          </p:cNvPr>
+          <p:cNvSpPr/>
+          <p:nvPr/>
+        </p:nvSpPr>
+        <p:spPr>
+          <a:xfrm>
+            <a:off x="6207707" y="3405290"/>
+            <a:ext cx="1481038" cy="1906497"/>
+          </a:xfrm>
+          <a:prstGeom prst="rect">
+            <a:avLst/>
+          </a:prstGeom>
+          <a:solidFill>
+            <a:schemeClr val="bg2">
+              <a:lumMod val="90000"/>
+            </a:schemeClr>
+          </a:solidFill>
+        </p:spPr>
+        <p:style>
+          <a:lnRef idx="2">
+            <a:schemeClr val="accent1">
+              <a:shade val="15000"/>
+            </a:schemeClr>
+          </a:lnRef>
+          <a:fillRef idx="1">
+            <a:schemeClr val="accent1"/>
+          </a:fillRef>
+          <a:effectRef idx="0">
+            <a:schemeClr val="accent1"/>
+          </a:effectRef>
+          <a:fontRef idx="minor">
+            <a:schemeClr val="lt1"/>
+          </a:fontRef>
+        </p:style>
+        <p:txBody>
+          <a:bodyPr rtlCol="0" anchor="ctr"/>
+          <a:lstStyle/>
+          <a:p>
+            <a:pPr algn="ctr"/>
+            <a:r>
+              <a:rPr lang="en-US" dirty="0"/>
+              <a:t>From Christoph add: </a:t>
+            </a:r>
+          </a:p>
+          <a:p>
+            <a:pPr algn="ctr"/>
+            <a:endParaRPr lang="en-US" dirty="0"/>
+          </a:p>
+          <a:p>
+            <a:pPr algn="ctr"/>
+            <a:r>
+              <a:rPr lang="en-US" dirty="0"/>
+              <a:t>D11 </a:t>
+            </a:r>
+            <a:r>
+              <a:rPr lang="en-US" dirty="0" err="1"/>
+              <a:t>stepSize</a:t>
+            </a:r>
+            <a:endParaRPr lang="en-US" dirty="0"/>
+          </a:p>
+          <a:p>
+            <a:pPr algn="ctr"/>
+            <a:r>
+              <a:rPr lang="en-US"/>
+              <a:t>D1</a:t>
+            </a:r>
+            <a:r>
+              <a:rPr lang="en-US" dirty="0"/>
+              <a:t>2</a:t>
+            </a:r>
+            <a:r>
+              <a:rPr lang="en-US"/>
+              <a:t> </a:t>
+            </a:r>
+            <a:r>
+              <a:rPr lang="en-US" dirty="0" err="1"/>
+              <a:t>calcTime</a:t>
+            </a:r>
+            <a:endParaRPr lang="en-US" dirty="0"/>
           </a:p>
         </p:txBody>
       </p:sp>

</xml_diff>